<commit_message>
Include the trained weights and organizer demo so a download from the hub runs as-is.
Co-authored-by: Cursor <cursoragent@cursor.com>
</commit_message>
<xml_diff>
--- a/docs/Презентация.pptx
+++ b/docs/Презентация.pptx
@@ -3180,7 +3180,7 @@
                 </a:solidFill>
                 <a:latin typeface="Segoe UI"/>
               </a:rPr>
-              <a:t>BUILD WATCH</a:t>
+              <a:t>СТРОЙРАДАР</a:t>
             </a:r>
           </a:p>
         </p:txBody>
@@ -3719,7 +3719,7 @@
                 </a:solidFill>
                 <a:latin typeface="Segoe UI"/>
               </a:rPr>
-              <a:t>Карточка объекта: пояснение отклонения, загруженные снимки, календарный план и таймлайн с переходом к конкретному кадру.</a:t>
+              <a:t>Карточка объекта: календарный план и таймлайн. Предупреждение за день открывается кнопкой «Открыть».</a:t>
             </a:r>
           </a:p>
         </p:txBody>
@@ -5318,7 +5318,7 @@
                           </a:solidFill>
                           <a:latin typeface="Segoe UI"/>
                         </a:rPr>
-                        <a:t>Методика «этап → техника»: 4 этапа, маркеры и звенья, план из CSV и Excel</a:t>
+                        <a:t>Методика «этап → техника»: 5 этапов, маркеры и звенья, план из CSV и Excel</a:t>
                       </a:r>
                     </a:p>
                   </a:txBody>
@@ -10508,7 +10508,7 @@
                 </a:solidFill>
                 <a:latin typeface="Segoe UI"/>
               </a:rPr>
-              <a:t>По плану 10 марта идут земляные работы в зоне «Котлован А». На кадрах за этот день система видит экскаватор — маркер этапа на месте, работы действительно начались. Но самосвалов и грузовиков в кадре нет: звено вывоза грунта разорвано. Пользователь получает предупреждение о возможном снижении темпа работ с указанием зоны и ссылками на снимки-подтверждения.</a:t>
+              <a:t>По плану 10 марта идёт откопка котлована в зоне «Котлован А». На кадрах за этот день система видит экскаватор — маркер этапа на месте, работы действительно начались. Но самосвалов и грузовиков в кадре нет: звено вывоза грунта разорвано. Пользователь получает предупреждение о возможном снижении темпа работ с указанием зоны и ссылками на снимки-подтверждения.</a:t>
             </a:r>
           </a:p>
         </p:txBody>
@@ -10701,8 +10701,8 @@
           <p:nvPr/>
         </p:nvGraphicFramePr>
         <p:xfrm>
-          <a:off x="658368" y="2532888"/>
-          <a:ext cx="10874959" cy="1920240"/>
+          <a:off x="658368" y="2414016"/>
+          <a:ext cx="10874959" cy="2304288"/>
         </p:xfrm>
         <a:graphic>
           <a:graphicData uri="http://schemas.openxmlformats.org/drawingml/2006/table">
@@ -10819,7 +10819,7 @@
                           </a:solidFill>
                           <a:latin typeface="Segoe UI"/>
                         </a:rPr>
-                        <a:t>Земляные работы / котлован</a:t>
+                        <a:t>Расчистка участка</a:t>
                       </a:r>
                     </a:p>
                   </a:txBody>
@@ -10841,7 +10841,97 @@
                           </a:solidFill>
                           <a:latin typeface="Segoe UI"/>
                         </a:rPr>
-                        <a:t>экскаватор, бульдозер</a:t>
+                        <a:t>бульдозер, погрузчик</a:t>
+                      </a:r>
+                    </a:p>
+                  </a:txBody>
+                  <a:tcPr anchor="ctr">
+                    <a:solidFill>
+                      <a:srgbClr val="141A24"/>
+                    </a:solidFill>
+                  </a:tcPr>
+                </a:tc>
+                <a:tc>
+                  <a:txBody>
+                    <a:bodyPr/>
+                    <a:lstStyle/>
+                    <a:p>
+                      <a:r>
+                        <a:rPr sz="1150" b="0">
+                          <a:solidFill>
+                            <a:srgbClr val="96A1B2"/>
+                          </a:solidFill>
+                          <a:latin typeface="Segoe UI"/>
+                        </a:rPr>
+                        <a:t>самосвал или грузовик</a:t>
+                      </a:r>
+                    </a:p>
+                  </a:txBody>
+                  <a:tcPr anchor="ctr">
+                    <a:solidFill>
+                      <a:srgbClr val="141A24"/>
+                    </a:solidFill>
+                  </a:tcPr>
+                </a:tc>
+                <a:tc>
+                  <a:txBody>
+                    <a:bodyPr/>
+                    <a:lstStyle/>
+                    <a:p>
+                      <a:r>
+                        <a:rPr sz="1150" b="0">
+                          <a:solidFill>
+                            <a:srgbClr val="96A1B2"/>
+                          </a:solidFill>
+                          <a:latin typeface="Segoe UI"/>
+                        </a:rPr>
+                        <a:t>вывозить нечем</a:t>
+                      </a:r>
+                    </a:p>
+                  </a:txBody>
+                  <a:tcPr anchor="ctr">
+                    <a:solidFill>
+                      <a:srgbClr val="141A24"/>
+                    </a:solidFill>
+                  </a:tcPr>
+                </a:tc>
+              </a:tr>
+              <a:tr h="384048">
+                <a:tc>
+                  <a:txBody>
+                    <a:bodyPr/>
+                    <a:lstStyle/>
+                    <a:p>
+                      <a:r>
+                        <a:rPr sz="1150" b="1">
+                          <a:solidFill>
+                            <a:srgbClr val="E8EBF0"/>
+                          </a:solidFill>
+                          <a:latin typeface="Segoe UI"/>
+                        </a:rPr>
+                        <a:t>Откопка котлована</a:t>
+                      </a:r>
+                    </a:p>
+                  </a:txBody>
+                  <a:tcPr anchor="ctr">
+                    <a:solidFill>
+                      <a:srgbClr val="141A24"/>
+                    </a:solidFill>
+                  </a:tcPr>
+                </a:tc>
+                <a:tc>
+                  <a:txBody>
+                    <a:bodyPr/>
+                    <a:lstStyle/>
+                    <a:p>
+                      <a:r>
+                        <a:rPr sz="1150" b="0">
+                          <a:solidFill>
+                            <a:srgbClr val="96A1B2"/>
+                          </a:solidFill>
+                          <a:latin typeface="Segoe UI"/>
+                        </a:rPr>
+                        <a:t>экскаватор</a:t>
                       </a:r>
                     </a:p>
                   </a:txBody>
@@ -10909,7 +10999,7 @@
                           </a:solidFill>
                           <a:latin typeface="Segoe UI"/>
                         </a:rPr>
-                        <a:t>Свайный фундамент</a:t>
+                        <a:t>Устройство фундаментов</a:t>
                       </a:r>
                     </a:p>
                   </a:txBody>
@@ -10999,7 +11089,7 @@
                           </a:solidFill>
                           <a:latin typeface="Segoe UI"/>
                         </a:rPr>
-                        <a:t>Монолитные работы</a:t>
+                        <a:t>Монтаж каркаса</a:t>
                       </a:r>
                     </a:p>
                   </a:txBody>
@@ -11021,7 +11111,7 @@
                           </a:solidFill>
                           <a:latin typeface="Segoe UI"/>
                         </a:rPr>
-                        <a:t>бетономешалка, бетононасос</a:t>
+                        <a:t>кран, миксер или насос</a:t>
                       </a:r>
                     </a:p>
                   </a:txBody>
@@ -11043,7 +11133,7 @@
                           </a:solidFill>
                           <a:latin typeface="Segoe UI"/>
                         </a:rPr>
-                        <a:t>бетономешалка + бетононасос</a:t>
+                        <a:t>миксер и насос, если бетон уже есть</a:t>
                       </a:r>
                     </a:p>
                   </a:txBody>
@@ -11089,7 +11179,7 @@
                           </a:solidFill>
                           <a:latin typeface="Segoe UI"/>
                         </a:rPr>
-                        <a:t>Надземная часть / монтаж</a:t>
+                        <a:t>Благоустройство</a:t>
                       </a:r>
                     </a:p>
                   </a:txBody>
@@ -11111,7 +11201,7 @@
                           </a:solidFill>
                           <a:latin typeface="Segoe UI"/>
                         </a:rPr>
-                        <a:t>башенный кран, автокран, кран-манипулятор</a:t>
+                        <a:t>каток</a:t>
                       </a:r>
                     </a:p>
                   </a:txBody>
@@ -11178,7 +11268,7 @@
         </p:nvSpPr>
         <p:spPr>
           <a:xfrm>
-            <a:off x="658368" y="4544568"/>
+            <a:off x="658368" y="4818888"/>
             <a:ext cx="10874959" cy="640080"/>
           </a:xfrm>
           <a:prstGeom prst="rect">
@@ -11204,7 +11294,7 @@
                 </a:solidFill>
                 <a:latin typeface="Segoe UI"/>
               </a:rPr>
-              <a:t>Погрузчик, самосвал, грузовик и каток объявлены вспомогательными: сами по себе они не открывают этап, иначе проехавший самосвал переводил бы площадку в «земляные работы».</a:t>
+              <a:t>Самосвал, грузовик, автокран и кран-манипулятор сами этап не открывают. Каток вместе с экскаватором или бульдозером остаётся котлованом или расчисткой. Башенный кран без бетона звено не требует.</a:t>
             </a:r>
           </a:p>
         </p:txBody>
@@ -11656,7 +11746,7 @@
                 </a:solidFill>
                 <a:latin typeface="Segoe UI"/>
               </a:rPr>
-              <a:t>Критично · incomplete_link</a:t>
+              <a:t>Простой · incomplete_link</a:t>
             </a:r>
           </a:p>
         </p:txBody>
@@ -12509,7 +12599,7 @@
                 </a:solidFill>
                 <a:latin typeface="Segoe UI"/>
               </a:rPr>
-              <a:t>ТЗ не даёт отдельного набора для проверки, поэтому он формируется скриптом eval_model.py: 86 кадров раскладываются по условиям съёмки и прогоняются через модель.</a:t>
+              <a:t>ТЗ не даёт отдельного набора для проверки, его собирает eval_model.py.</a:t>
             </a:r>
           </a:p>
           <a:p>
@@ -12541,6 +12631,22 @@
                 </a:solidFill>
                 <a:latin typeface="Segoe UI"/>
               </a:rPr>
+              <a:t>В отчёте: просмотрено 86 кадров, отобрано 17, задействовано 10 из 12 классов.</a:t>
+            </a:r>
+          </a:p>
+          <a:p>
+            <a:pPr algn="l">
+              <a:lnSpc>
+                <a:spcPct val="130000"/>
+              </a:lnSpc>
+            </a:pPr>
+            <a:r>
+              <a:rPr sz="1200" b="0">
+                <a:solidFill>
+                  <a:srgbClr val="96A1B2"/>
+                </a:solidFill>
+                <a:latin typeface="Segoe UI"/>
+              </a:rPr>
               <a:t>Освещённость: яркий день, пасмурно, сумерки и контраст.</a:t>
             </a:r>
           </a:p>
@@ -12558,22 +12664,6 @@
                 <a:latin typeface="Segoe UI"/>
               </a:rPr>
               <a:t>Фон и сезон: зелёный сезон, снег и межсезонье, без зелени.</a:t>
-            </a:r>
-          </a:p>
-          <a:p>
-            <a:pPr algn="l">
-              <a:lnSpc>
-                <a:spcPct val="130000"/>
-              </a:lnSpc>
-            </a:pPr>
-            <a:r>
-              <a:rPr sz="1200" b="0">
-                <a:solidFill>
-                  <a:srgbClr val="96A1B2"/>
-                </a:solidFill>
-                <a:latin typeface="Segoe UI"/>
-              </a:rPr>
-              <a:t>Задействовано 10 из 12 классов техники.</a:t>
             </a:r>
           </a:p>
           <a:p>

</xml_diff>